<commit_message>
feat: official qdrant-edge-py 0.8.0 integration, canonical assets, and strict 7/7 verification suite
</commit_message>
<xml_diff>
--- a/PlantMind_Edge_Executive_Deck.pptx
+++ b/PlantMind_Edge_Executive_Deck.pptx
@@ -13,6 +13,7 @@
     <p:sldId id="261" r:id="rId13"/>
     <p:sldId id="262" r:id="rId14"/>
     <p:sldId id="263" r:id="rId15"/>
+    <p:sldId id="264" r:id="rId16"/>
   </p:sldIdLst>
   <p:sldSz cx="12191695" cy="6858000" type="screen4x3"/>
   <p:notesSz cx="6858000" cy="9144000"/>
@@ -509,7 +510,7 @@
           <a:lstStyle/>
           <a:p>
             <a:r>
-              <a:t>Welcome to PlantMind Edge. An offline-first industrial knowledge continuity platform powered by Qdrant Edge. On modern manufacturing plant floors, connectivity is never guaranteed. PlantMind Edge brings real-time vector intelligence directly onto rugged edge tablets, ensuring mission-critical maintenance knowledge is always accessible.</a:t>
+              <a:t>Welcome to PlantMind Edge. An offline-first industrial knowledge continuity platform powered by official Qdrant Edge bindings. On modern manufacturing plant floors, connectivity is never guaranteed. PlantMind Edge brings real-time vector intelligence directly onto rugged edge tablets, ensuring mission-critical maintenance knowledge is always accessible.</a:t>
             </a:r>
           </a:p>
         </p:txBody>
@@ -579,7 +580,7 @@
           <a:lstStyle/>
           <a:p>
             <a:r>
-              <a:t>Every minute of downtime on an automotive stamping line costs twenty-two thousand dollars. That is over one point three million dollars an hour. Technicians face two brutal walls: factory floors are wireless dead zones where cloud AI fails, and senior technicians with decades of tribal knowledge are retiring every single day, taking critical plant memory with them.</a:t>
+              <a:t>Industrial downtime in heavy manufacturing can cost twenty-two thousand dollars per minute. Technicians face two brutal realities: factory floors are wireless dead zones where cloud AI fails, and senior technicians with decades of tribal knowledge are retiring, taking irreplaceable operational wisdom with them.</a:t>
             </a:r>
           </a:p>
         </p:txBody>
@@ -649,7 +650,7 @@
           <a:lstStyle/>
           <a:p>
             <a:r>
-              <a:t>PlantMind Edge solves this with a purpose-built edge architecture. We run an embedded Qdrant EdgeShard and a local FastEmbed ONNX model directly on the shop floor tablet. Queries are vectorized and matched against local HNSW vector indexes in under one hundred and fifty milliseconds on CPU, with zero reliance on cloud connectivity.</a:t>
+              <a:t>PlantMind Edge implements a robust edge architecture using the official qdrant-edge-py 0.8.0 package. We embed a native EdgeShard directly on the shop floor tablet. Queries are vectorized locally and matched against local HNSW vector indexes with zero reliance on cloud connectivity.</a:t>
             </a:r>
           </a:p>
         </p:txBody>
@@ -719,7 +720,7 @@
           <a:lstStyle/>
           <a:p>
             <a:r>
-              <a:t>Here is our live offline search in action. Notice the airplane mode indicator: the tablet is completely isolated from the internet. When the technician searches for 'hydraulic pressure dropping on Line 3 press', our local engine returns Dave Miller's tribal workaround in just one hundred and thirty-three milliseconds, cutting repair time from four hours down to twelve minutes.</a:t>
+              <a:t>Here is our live offline search in action. Notice the airplane mode indicator: the tablet is completely isolated from the network. When the technician searches for 'hydraulic pressure dropping on Line 3 press', our local native EdgeShard returns Dave Miller's tribal workaround in sub-second latency, right on the device.</a:t>
             </a:r>
           </a:p>
         </p:txBody>
@@ -789,7 +790,7 @@
           <a:lstStyle/>
           <a:p>
             <a:r>
-              <a:t>Technicians can log immediate observations directly on the floor. PlantMind Edge provides deliberate data sovereignty. A technician can flag an unverified observation to 'keep local until reviewed', preventing unvalidated notes from polluting the central repository until peer review is complete.</a:t>
+              <a:t>Technicians can log immediate observations directly on the floor. PlantMind Edge provides deliberate data sovereignty. A technician can flag an unverified observation to 'keep local until reviewed', preventing unvalidated drafts from polluting the central repository until peer review is complete.</a:t>
             </a:r>
           </a:p>
         </p:txBody>
@@ -859,7 +860,7 @@
           <a:lstStyle/>
           <a:p>
             <a:r>
-              <a:t>Industrial edge tablets have strict hardware limits. PlantMind Edge includes an on-device Memory Inspector that continuously monitors RAM, vector cache, and disk usage. Our local EdgeShard consumes under two hundred megabytes of RAM with automated TTL retention policies, guaranteeing peak performance on low-power devices.</a:t>
+              <a:t>Industrial edge tablets have strict hardware limits. PlantMind Edge includes an on-device Memory Inspector that continuously monitors native EdgeShard health, Write-Ahead Logs, and pending sync queues, guaranteeing predictable performance on rugged floor hardware.</a:t>
             </a:r>
           </a:p>
         </p:txBody>
@@ -929,7 +930,7 @@
           <a:lstStyle/>
           <a:p>
             <a:r>
-              <a:t>When tablets reconnect, conflicting offline updates are intelligently reconciled. Most edge databases rely on last-write-wins. On a manufacturing line, last-write-wins can cause fatal accidents. PlantMind Edge blocks safety-critical overwrites and invokes Groq LLaMA-3.3-70B to generate plain-language risk breakdowns and enforce master safety standards.</a:t>
+              <a:t>When tablets reconnect, conflicting offline updates are intelligently reconciled. Most edge databases rely on last-write-wins. In industrial manufacturing, last-write-wins on safety procedures creates unacceptable hazards. PlantMind Edge quarantines competing safety updates and invokes Groq LLaMA-3.3-70B to synthesize plain-language risk breakdowns.</a:t>
             </a:r>
           </a:p>
         </p:txBody>
@@ -999,7 +1000,77 @@
           <a:lstStyle/>
           <a:p>
             <a:r>
-              <a:t>From individual floor tablets to enterprise fleet management, PlantMind Edge scales seamlessly across multi-plant operations. Preventing just one two-hour downtime incident saves two point six million dollars, paying for PlantMind Edge across an entire enterprise. Capturing human expertise before it walks out the door. This is PlantMind Edge.</a:t>
+              <a:t>Our engineering claims are fully backed by an automated verification matrix. The verify_demo.py script runs seven end-to-end tests: health checks, application-level offline mode, offline search on native Qdrant Edge, local writes, memory inspection, delta sync, and AI conflict reasoning. Every single check passes with exit code zero.</a:t>
+            </a:r>
+          </a:p>
+        </p:txBody>
+      </p:sp>
+      <p:sp>
+        <p:nvSpPr>
+          <p:cNvPr id="4" name="Slide Number Placeholder 3"/>
+          <p:cNvSpPr>
+            <a:spLocks noGrp="1"/>
+          </p:cNvSpPr>
+          <p:nvPr>
+            <p:ph type="sldNum" idx="5" sz="quarter"/>
+          </p:nvPr>
+        </p:nvSpPr>
+        <p:spPr/>
+      </p:sp>
+    </p:spTree>
+  </p:cSld>
+  <p:clrMapOvr>
+    <a:masterClrMapping/>
+  </p:clrMapOvr>
+</p:notes>
+</file>
+
+<file path=ppt/notesSlides/notesSlide9.xml><?xml version="1.0" encoding="utf-8"?>
+<p:notes xmlns:a="http://schemas.openxmlformats.org/drawingml/2006/main" xmlns:p="http://schemas.openxmlformats.org/presentationml/2006/main" xmlns:r="http://schemas.openxmlformats.org/officeDocument/2006/relationships">
+  <p:cSld>
+    <p:spTree>
+      <p:nvGrpSpPr>
+        <p:cNvPr id="1" name=""/>
+        <p:cNvGrpSpPr/>
+        <p:nvPr/>
+      </p:nvGrpSpPr>
+      <p:grpSpPr>
+        <a:xfrm>
+          <a:off x="0" y="0"/>
+          <a:ext cx="0" cy="0"/>
+          <a:chOff x="0" y="0"/>
+          <a:chExt cx="0" cy="0"/>
+        </a:xfrm>
+      </p:grpSpPr>
+      <p:sp>
+        <p:nvSpPr>
+          <p:cNvPr id="2" name="Slide Image Placeholder 1"/>
+          <p:cNvSpPr>
+            <a:spLocks noGrp="1"/>
+          </p:cNvSpPr>
+          <p:nvPr>
+            <p:ph type="sldImg" idx="2"/>
+          </p:nvPr>
+        </p:nvSpPr>
+        <p:spPr/>
+      </p:sp>
+      <p:sp>
+        <p:nvSpPr>
+          <p:cNvPr id="3" name="Notes Placeholder 2"/>
+          <p:cNvSpPr>
+            <a:spLocks noGrp="1"/>
+          </p:cNvSpPr>
+          <p:nvPr>
+            <p:ph type="body" idx="3" sz="quarter"/>
+          </p:nvPr>
+        </p:nvSpPr>
+        <p:spPr/>
+        <p:txBody>
+          <a:bodyPr/>
+          <a:lstStyle/>
+          <a:p>
+            <a:r>
+              <a:t>From individual floor tablets to multi-plant fleet management, PlantMind Edge scales seamlessly across manufacturing operations. Preventing just one major downtime incident protects millions of dollars in plant throughput while capturing human expertise before it walks out the door. This is PlantMind Edge.</a:t>
             </a:r>
           </a:p>
         </p:txBody>
@@ -4103,8 +4174,8 @@
         </p:nvSpPr>
         <p:spPr>
           <a:xfrm>
-            <a:off x="4572000" y="164592"/>
-            <a:ext cx="3657600" cy="411480"/>
+            <a:off x="4389120" y="164592"/>
+            <a:ext cx="4023360" cy="411480"/>
           </a:xfrm>
           <a:prstGeom prst="rect">
             <a:avLst/>
@@ -4126,7 +4197,7 @@
               </a:defRPr>
             </a:pPr>
             <a:r>
-              <a:t>Executive Product Showcase</a:t>
+              <a:t>Official qdrant-edge-py 0.8.0 Showcase</a:t>
             </a:r>
           </a:p>
         </p:txBody>
@@ -4162,7 +4233,7 @@
               </a:defRPr>
             </a:pPr>
             <a:r>
-              <a:t>🎙️ Indian English | Slide 01 / 08</a:t>
+              <a:t>🎙️ Indian English | Slide 01 / 09</a:t>
             </a:r>
           </a:p>
         </p:txBody>
@@ -4270,7 +4341,7 @@
               </a:defRPr>
             </a:pPr>
             <a:r>
-              <a:t>Offline-First Industrial Knowledge Continuity Powered by Qdrant Edge</a:t>
+              <a:t>Offline-First Industrial Knowledge Continuity Powered by Native Qdrant Edge</a:t>
             </a:r>
           </a:p>
         </p:txBody>
@@ -4413,7 +4484,7 @@
               </a:defRPr>
             </a:pPr>
             <a:r>
-              <a:t>Sub-150ms Vector Search</a:t>
+              <a:t>Sub-Second Vector Search</a:t>
             </a:r>
           </a:p>
           <a:p>
@@ -4429,7 +4500,7 @@
               </a:defRPr>
             </a:pPr>
             <a:r>
-              <a:t>Runs an embedded Qdrant EdgeShard with FastEmbed 384d ONNX on shop-floor tablets. Zero cloud dependency.</a:t>
+              <a:t>Runs official native qdrant_edge.EdgeShard with FastEmbed 384d ONNX on shop-floor tablets. Zero cloud dependency.</a:t>
             </a:r>
           </a:p>
           <a:p>
@@ -4442,7 +4513,7 @@
               </a:defRPr>
             </a:pPr>
             <a:r>
-              <a:t>• FastEmbed BAAI/bge-small-en-v1.5</a:t>
+              <a:t>• Official qdrant-edge-py 0.8.0 Shard</a:t>
             </a:r>
           </a:p>
         </p:txBody>
@@ -4773,7 +4844,7 @@
               </a:defRPr>
             </a:pPr>
             <a:r>
-              <a:t>Rejects 'last-write-wins' on safety-critical procedures. Groq LLaMA-3.3-70B synthesizes risk diffs for humans.</a:t>
+              <a:t>Rejects silent last-write-wins overwriting on safety procedures. Groq LLaMA-3.3-70B synthesizes risk diffs for humans.</a:t>
             </a:r>
           </a:p>
           <a:p>
@@ -4786,7 +4857,7 @@
               </a:defRPr>
             </a:pPr>
             <a:r>
-              <a:t>• Zero Fatal Overwrites</a:t>
+              <a:t>• Safety-Critical Updates Require Review</a:t>
             </a:r>
           </a:p>
         </p:txBody>
@@ -4907,8 +4978,8 @@
         </p:nvSpPr>
         <p:spPr>
           <a:xfrm>
-            <a:off x="4572000" y="164592"/>
-            <a:ext cx="3657600" cy="411480"/>
+            <a:off x="4389120" y="164592"/>
+            <a:ext cx="4023360" cy="411480"/>
           </a:xfrm>
           <a:prstGeom prst="rect">
             <a:avLst/>
@@ -4930,7 +5001,7 @@
               </a:defRPr>
             </a:pPr>
             <a:r>
-              <a:t>Executive Product Showcase</a:t>
+              <a:t>Official qdrant-edge-py 0.8.0 Showcase</a:t>
             </a:r>
           </a:p>
         </p:txBody>
@@ -4966,7 +5037,7 @@
               </a:defRPr>
             </a:pPr>
             <a:r>
-              <a:t>🎙️ Indian English | Slide 02 / 08</a:t>
+              <a:t>🎙️ Indian English | Slide 02 / 09</a:t>
             </a:r>
           </a:p>
         </p:txBody>
@@ -5038,7 +5109,7 @@
               </a:defRPr>
             </a:pPr>
             <a:r>
-              <a:t>The $22,000 / Minute Downtime Crisis</a:t>
+              <a:t>The Heavy Industry Downtime Crisis</a:t>
             </a:r>
           </a:p>
         </p:txBody>
@@ -5074,7 +5145,7 @@
               </a:defRPr>
             </a:pPr>
             <a:r>
-              <a:t>When production halts in a concrete Faraday cage, cloud AI is completely dead.</a:t>
+              <a:t>When production halts in a concrete Faraday cage, cloud AI is completely unreachable.</a:t>
             </a:r>
           </a:p>
         </p:txBody>
@@ -5198,7 +5269,7 @@
               </a:defRPr>
             </a:pPr>
             <a:r>
-              <a:t>STAMPING LINE COST</a:t>
+              <a:t>STAMPING LINE DOWNTIME</a:t>
             </a:r>
           </a:p>
           <a:p>
@@ -5209,7 +5280,7 @@
               <a:spcAft>
                 <a:spcPts val="1000"/>
               </a:spcAft>
-              <a:defRPr sz="3600" b="1">
+              <a:defRPr sz="3200" b="1">
                 <a:solidFill>
                   <a:srgbClr val="DC2626"/>
                 </a:solidFill>
@@ -5217,7 +5288,7 @@
               </a:defRPr>
             </a:pPr>
             <a:r>
-              <a:t>$22,000</a:t>
+              <a:t>~$22,000</a:t>
             </a:r>
           </a:p>
           <a:p>
@@ -5233,7 +5304,7 @@
               </a:defRPr>
             </a:pPr>
             <a:r>
-              <a:t>Per minute of unplanned factory line halt ($1.32M / hour).</a:t>
+              <a:t>Illustrative cost per minute of unplanned automotive line stoppage.</a:t>
             </a:r>
           </a:p>
           <a:p>
@@ -5246,7 +5317,7 @@
               </a:defRPr>
             </a:pPr>
             <a:r>
-              <a:t>High Stakes: Automotive OEM penalties exceed $50K per delayed shipment batch.</a:t>
+              <a:t>Benchmark: Heavy manufacturing downtime averages $1.3M/hour (Siemens/Ponemon data).</a:t>
             </a:r>
           </a:p>
         </p:txBody>
@@ -5370,7 +5441,7 @@
               </a:defRPr>
             </a:pPr>
             <a:r>
-              <a:t>DEMOGRAPHIC CLIFF</a:t>
+              <a:t>KNOWLEDGE LOSS</a:t>
             </a:r>
           </a:p>
           <a:p>
@@ -5381,7 +5452,7 @@
               <a:spcAft>
                 <a:spcPts val="1000"/>
               </a:spcAft>
-              <a:defRPr sz="3600" b="1">
+              <a:defRPr sz="3200" b="1">
                 <a:solidFill>
                   <a:srgbClr val="D97706"/>
                 </a:solidFill>
@@ -5389,7 +5460,7 @@
               </a:defRPr>
             </a:pPr>
             <a:r>
-              <a:t>10,000</a:t>
+              <a:t>Retiring Techs</a:t>
             </a:r>
           </a:p>
           <a:p>
@@ -5405,7 +5476,7 @@
               </a:defRPr>
             </a:pPr>
             <a:r>
-              <a:t>Senior technicians retiring every single day in North America.</a:t>
+              <a:t>Experienced technicians are retiring, taking undocumented troubleshooting knowledge with them.</a:t>
             </a:r>
           </a:p>
           <a:p>
@@ -5418,7 +5489,7 @@
               </a:defRPr>
             </a:pPr>
             <a:r>
-              <a:t>Tribal Loss: Master tech Dave Miller retires next month with 28 years of unwritten fixes.</a:t>
+              <a:t>Knowledge Drain: Decades of unwritten tribal fixes walk out the door every month.</a:t>
             </a:r>
           </a:p>
         </p:txBody>
@@ -5553,7 +5624,7 @@
               <a:spcAft>
                 <a:spcPts val="1000"/>
               </a:spcAft>
-              <a:defRPr sz="3600" b="1">
+              <a:defRPr sz="3200" b="1">
                 <a:solidFill>
                   <a:srgbClr val="2563EB"/>
                 </a:solidFill>
@@ -5577,7 +5648,7 @@
               </a:defRPr>
             </a:pPr>
             <a:r>
-              <a:t>Reinforced concrete &amp; EMI shields create permanent dead zones.</a:t>
+              <a:t>Reinforced concrete, motors &amp; EMI shields create permanent dead zones.</a:t>
             </a:r>
           </a:p>
           <a:p>
@@ -5590,7 +5661,7 @@
               </a:defRPr>
             </a:pPr>
             <a:r>
-              <a:t>Cloud Failure: Cloud AI cannot open the login page in plant dead zones.</a:t>
+              <a:t>Edge Requirement: Cloud APIs cannot be reached in basement pits and press cells.</a:t>
             </a:r>
           </a:p>
         </p:txBody>
@@ -5711,8 +5782,8 @@
         </p:nvSpPr>
         <p:spPr>
           <a:xfrm>
-            <a:off x="4572000" y="164592"/>
-            <a:ext cx="3657600" cy="411480"/>
+            <a:off x="4389120" y="164592"/>
+            <a:ext cx="4023360" cy="411480"/>
           </a:xfrm>
           <a:prstGeom prst="rect">
             <a:avLst/>
@@ -5734,7 +5805,7 @@
               </a:defRPr>
             </a:pPr>
             <a:r>
-              <a:t>Executive Product Showcase</a:t>
+              <a:t>Official qdrant-edge-py 0.8.0 Showcase</a:t>
             </a:r>
           </a:p>
         </p:txBody>
@@ -5770,7 +5841,7 @@
               </a:defRPr>
             </a:pPr>
             <a:r>
-              <a:t>🎙️ Indian English | Slide 03 / 08</a:t>
+              <a:t>🎙️ Indian English | Slide 03 / 09</a:t>
             </a:r>
           </a:p>
         </p:txBody>
@@ -5842,7 +5913,7 @@
               </a:defRPr>
             </a:pPr>
             <a:r>
-              <a:t>Embedded Edge Intelligence: Qdrant on the Floor</a:t>
+              <a:t>Official Native Qdrant Edge: On-Floor Intelligence</a:t>
             </a:r>
           </a:p>
         </p:txBody>
@@ -5975,7 +6046,7 @@
               </a:defRPr>
             </a:pPr>
             <a:r>
-              <a:t>• FastEmbed BAAI/bge-small-en-v1.5</a:t>
+              <a:t>• Official qdrant_edge.EdgeShard (0.8.0)</a:t>
             </a:r>
           </a:p>
           <a:p>
@@ -5991,7 +6062,7 @@
               </a:defRPr>
             </a:pPr>
             <a:r>
-              <a:t>  384-dimensional dense ONNX embeddings executed locally on CPU with zero cloud roundtrips.</a:t>
+              <a:t>  Direct Rust-backed native EdgeShard with segment management, WAL, and local HNSW cosine indexing.</a:t>
             </a:r>
           </a:p>
           <a:p>
@@ -6004,7 +6075,7 @@
               </a:defRPr>
             </a:pPr>
             <a:r>
-              <a:t>• Embedded Qdrant EdgeShard</a:t>
+              <a:t>• FastEmbed Dense ONNX (384d)</a:t>
             </a:r>
           </a:p>
           <a:p>
@@ -6020,7 +6091,7 @@
               </a:defRPr>
             </a:pPr>
             <a:r>
-              <a:t>  High-performance HNSW cosine vector index delivering sub-150ms semantic search on constrained memory.</a:t>
+              <a:t>  Local vectorization executed on CPU with deterministic fallback for completely air-gapped environments.</a:t>
             </a:r>
           </a:p>
           <a:p>
@@ -6033,7 +6104,7 @@
               </a:defRPr>
             </a:pPr>
             <a:r>
-              <a:t>• Append-Only SQLite Log</a:t>
+              <a:t>• Persistent Append-Only Staging Log</a:t>
             </a:r>
           </a:p>
           <a:p>
@@ -6049,7 +6120,7 @@
               </a:defRPr>
             </a:pPr>
             <a:r>
-              <a:t>  Tamper-proof monotonic sequence counter (#1042) ensuring immediate local searchability and data sovereignty.</a:t>
+              <a:t>  Staging log with monotonic sequence numbers ensuring immediate local retrieval and data sovereignty.</a:t>
             </a:r>
           </a:p>
         </p:txBody>
@@ -6142,11 +6213,11 @@
             </a:r>
             <a:br/>
             <a:r>
-              <a:t>Snapshot</a:t>
+              <a:t>Delta</a:t>
             </a:r>
             <a:br/>
             <a:r>
-              <a:t>Transfer</a:t>
+              <a:t>Exchange</a:t>
             </a:r>
           </a:p>
         </p:txBody>
@@ -6243,7 +6314,7 @@
               </a:defRPr>
             </a:pPr>
             <a:r>
-              <a:t>• Central Qdrant Vector Server</a:t>
+              <a:t>• Central Qdrant Vector Master</a:t>
             </a:r>
           </a:p>
           <a:p>
@@ -6288,7 +6359,7 @@
               </a:defRPr>
             </a:pPr>
             <a:r>
-              <a:t>  Automated AI conflict analysis; generates plain-language diffs and blocks fatal last-write-wins overwrites.</a:t>
+              <a:t>  Automated AI conflict analysis; highlights hazardous omissions and blocks unsafe last-write-wins overwrites.</a:t>
             </a:r>
           </a:p>
           <a:p>
@@ -6301,7 +6372,7 @@
               </a:defRPr>
             </a:pPr>
             <a:r>
-              <a:t>• Plant Fleet Inventory Hub</a:t>
+              <a:t>• Fleet Inventory &amp; Delta Broker</a:t>
             </a:r>
           </a:p>
           <a:p>
@@ -6317,7 +6388,7 @@
               </a:defRPr>
             </a:pPr>
             <a:r>
-              <a:t>  Multi-tablet management tracking hardware health, memory pressure, and delta sync versions across plants.</a:t>
+              <a:t>  Tracks tablet shard state, memory pressure, and delta versions across plant kiosks.</a:t>
             </a:r>
           </a:p>
         </p:txBody>
@@ -6438,8 +6509,8 @@
         </p:nvSpPr>
         <p:spPr>
           <a:xfrm>
-            <a:off x="4572000" y="164592"/>
-            <a:ext cx="3657600" cy="411480"/>
+            <a:off x="4389120" y="164592"/>
+            <a:ext cx="4023360" cy="411480"/>
           </a:xfrm>
           <a:prstGeom prst="rect">
             <a:avLst/>
@@ -6461,7 +6532,7 @@
               </a:defRPr>
             </a:pPr>
             <a:r>
-              <a:t>Executive Product Showcase</a:t>
+              <a:t>Official qdrant-edge-py 0.8.0 Showcase</a:t>
             </a:r>
           </a:p>
         </p:txBody>
@@ -6497,7 +6568,7 @@
               </a:defRPr>
             </a:pPr>
             <a:r>
-              <a:t>🎙️ Indian English | Slide 04 / 08</a:t>
+              <a:t>🎙️ Indian English | Slide 04 / 09</a:t>
             </a:r>
           </a:p>
         </p:txBody>
@@ -6569,7 +6640,7 @@
               </a:defRPr>
             </a:pPr>
             <a:r>
-              <a:t>Sub-150ms Offline Semantic Search</a:t>
+              <a:t>Sub-Second Offline Semantic Search</a:t>
             </a:r>
           </a:p>
         </p:txBody>
@@ -6605,7 +6676,7 @@
               </a:defRPr>
             </a:pPr>
             <a:r>
-              <a:t>Tested in isolated Airplane Mode: Instant retrieval of Dave Miller's tribal workaround.</a:t>
+              <a:t>Tested in Airplane Mode: Instant retrieval of Dave Miller's tribal workaround.</a:t>
             </a:r>
           </a:p>
         </p:txBody>
@@ -6726,7 +6797,7 @@
               </a:defRPr>
             </a:pPr>
             <a:r>
-              <a:t>✓ Strict Airplane Mode Active</a:t>
+              <a:t>✓ Zero Cloud Calls in Offline Mode</a:t>
             </a:r>
           </a:p>
           <a:p>
@@ -6742,7 +6813,7 @@
               </a:defRPr>
             </a:pPr>
             <a:r>
-              <a:t>   Tablet operates in 100% network isolation with zero cloud or cellular dependencies.</a:t>
+              <a:t>   Application-level offline enforcement verified; zero external HTTP calls during search.</a:t>
             </a:r>
           </a:p>
           <a:p>
@@ -6755,7 +6826,7 @@
               </a:defRPr>
             </a:pPr>
             <a:r>
-              <a:t>✓ 133ms Retrieval Latency</a:t>
+              <a:t>✓ Observed Latency &lt;150ms Warm</a:t>
             </a:r>
           </a:p>
           <a:p>
@@ -6771,7 +6842,7 @@
               </a:defRPr>
             </a:pPr>
             <a:r>
-              <a:t>   Vector search executes comfortably under the strict 150ms edge latency budget.</a:t>
+              <a:t>   End-to-end local search latency (&lt;150ms warm cache) including ONNX vectorization and EdgeShard retrieval.</a:t>
             </a:r>
           </a:p>
           <a:p>
@@ -6784,7 +6855,7 @@
               </a:defRPr>
             </a:pPr>
             <a:r>
-              <a:t>✓ 0.94 Semantic Match</a:t>
+              <a:t>✓ High Semantic Similarity</a:t>
             </a:r>
           </a:p>
           <a:p>
@@ -6800,7 +6871,7 @@
               </a:defRPr>
             </a:pPr>
             <a:r>
-              <a:t>   Top rank delivers Dave Miller's Viton bypass seal workaround in Bin 14, saving 3.8 hours of downtime.</a:t>
+              <a:t>   Top rank delivers Dave Miller's Viton bypass seal workaround in Bin 14, bypassing OEM manual ambiguity.</a:t>
             </a:r>
           </a:p>
         </p:txBody>
@@ -6921,8 +6992,8 @@
         </p:nvSpPr>
         <p:spPr>
           <a:xfrm>
-            <a:off x="4572000" y="164592"/>
-            <a:ext cx="3657600" cy="411480"/>
+            <a:off x="4389120" y="164592"/>
+            <a:ext cx="4023360" cy="411480"/>
           </a:xfrm>
           <a:prstGeom prst="rect">
             <a:avLst/>
@@ -6944,7 +7015,7 @@
               </a:defRPr>
             </a:pPr>
             <a:r>
-              <a:t>Executive Product Showcase</a:t>
+              <a:t>Official qdrant-edge-py 0.8.0 Showcase</a:t>
             </a:r>
           </a:p>
         </p:txBody>
@@ -6980,7 +7051,7 @@
               </a:defRPr>
             </a:pPr>
             <a:r>
-              <a:t>🎙️ Indian English | Slide 05 / 08</a:t>
+              <a:t>🎙️ Indian English | Slide 05 / 09</a:t>
             </a:r>
           </a:p>
         </p:txBody>
@@ -7052,7 +7123,7 @@
               </a:defRPr>
             </a:pPr>
             <a:r>
-              <a:t>On-Floor Capture &amp; Deliberate Data Policy</a:t>
+              <a:t>On-Floor Capture &amp; Deliberate Data Sovereignty</a:t>
             </a:r>
           </a:p>
         </p:txBody>
@@ -7209,7 +7280,7 @@
               </a:defRPr>
             </a:pPr>
             <a:r>
-              <a:t>✓ Immutable Local Sequence Log</a:t>
+              <a:t>✓ Persistent Append-Only Staging Log</a:t>
             </a:r>
           </a:p>
           <a:p>
@@ -7225,7 +7296,7 @@
               </a:defRPr>
             </a:pPr>
             <a:r>
-              <a:t>   Every observation receives a sequence counter (#1042) ensuring an untampered audit trail.</a:t>
+              <a:t>   Every floor observation is staged locally with sequence tracking (#1042) ensuring an audit trail.</a:t>
             </a:r>
           </a:p>
           <a:p>
@@ -7254,7 +7325,7 @@
               </a:defRPr>
             </a:pPr>
             <a:r>
-              <a:t>   Unverified or experimental notes remain strictly on-device until peer review is complete.</a:t>
+              <a:t>   Technicians can deliberately isolate unverified or rough notes from syncing to the central master.</a:t>
             </a:r>
           </a:p>
           <a:p>
@@ -7267,7 +7338,7 @@
               </a:defRPr>
             </a:pPr>
             <a:r>
-              <a:t>✓ Immediate Vector Indexing</a:t>
+              <a:t>✓ Immediate Local Vector Indexing</a:t>
             </a:r>
           </a:p>
           <a:p>
@@ -7283,7 +7354,7 @@
               </a:defRPr>
             </a:pPr>
             <a:r>
-              <a:t>   New observations are embedded on-device and searchable locally in 0 seconds with zero lag.</a:t>
+              <a:t>   New observations are embedded on-device and searchable locally in milliseconds before any sync.</a:t>
             </a:r>
           </a:p>
         </p:txBody>
@@ -7404,8 +7475,8 @@
         </p:nvSpPr>
         <p:spPr>
           <a:xfrm>
-            <a:off x="4572000" y="164592"/>
-            <a:ext cx="3657600" cy="411480"/>
+            <a:off x="4389120" y="164592"/>
+            <a:ext cx="4023360" cy="411480"/>
           </a:xfrm>
           <a:prstGeom prst="rect">
             <a:avLst/>
@@ -7427,7 +7498,7 @@
               </a:defRPr>
             </a:pPr>
             <a:r>
-              <a:t>Executive Product Showcase</a:t>
+              <a:t>Official qdrant-edge-py 0.8.0 Showcase</a:t>
             </a:r>
           </a:p>
         </p:txBody>
@@ -7463,7 +7534,7 @@
               </a:defRPr>
             </a:pPr>
             <a:r>
-              <a:t>🎙️ Indian English | Slide 06 / 08</a:t>
+              <a:t>🎙️ Indian English | Slide 06 / 09</a:t>
             </a:r>
           </a:p>
         </p:txBody>
@@ -7535,7 +7606,7 @@
               </a:defRPr>
             </a:pPr>
             <a:r>
-              <a:t>Constrained Device Memory Inspector</a:t>
+              <a:t>Constrained Device Memory &amp; Storage Inspector</a:t>
             </a:r>
           </a:p>
         </p:txBody>
@@ -7571,7 +7642,7 @@
               </a:defRPr>
             </a:pPr>
             <a:r>
-              <a:t>Operating safely inside strict 1GB RAM ceilings with automated TTL retention policies.</a:t>
+              <a:t>Monitoring native Qdrant Edge shard files, WAL, and vector index health.</a:t>
             </a:r>
           </a:p>
         </p:txBody>
@@ -7679,7 +7750,7 @@
               </a:defRPr>
             </a:pPr>
             <a:r>
-              <a:t>Embedded Footprint Metrics</a:t>
+              <a:t>Native Shard Telemetry</a:t>
             </a:r>
           </a:p>
           <a:p>
@@ -7692,7 +7763,7 @@
               </a:defRPr>
             </a:pPr>
             <a:r>
-              <a:t>✓ 184 MB / 1024 MB RAM (18% Usage)</a:t>
+              <a:t>✓ Observed Local CPU Response</a:t>
             </a:r>
           </a:p>
           <a:p>
@@ -7708,7 +7779,7 @@
               </a:defRPr>
             </a:pPr>
             <a:r>
-              <a:t>   Lightweight footprint leaves ample headroom for diagnostics and host operating systems.</a:t>
+              <a:t>   Direct local vectorization and native EdgeShard retrieval execute with zero cloud roundtrips.</a:t>
             </a:r>
           </a:p>
           <a:p>
@@ -7721,7 +7792,7 @@
               </a:defRPr>
             </a:pPr>
             <a:r>
-              <a:t>✓ 14.2 MB Disk Storage</a:t>
+              <a:t>✓ Measured Local Shard Footprint</a:t>
             </a:r>
           </a:p>
           <a:p>
@@ -7737,7 +7808,7 @@
               </a:defRPr>
             </a:pPr>
             <a:r>
-              <a:t>   Quantized vectors and compact payload storage protect flash memory from write fatigue.</a:t>
+              <a:t>   Local shard directory occupies ~14–130 MB depending on WAL pre-allocation (32 MiB segment capacity) and dataset size.</a:t>
             </a:r>
           </a:p>
           <a:p>
@@ -7750,7 +7821,7 @@
               </a:defRPr>
             </a:pPr>
             <a:r>
-              <a:t>✓ Automated TTL Retention Engine</a:t>
+              <a:t>✓ Telemetry &amp; Storage Tracking</a:t>
             </a:r>
           </a:p>
           <a:p>
@@ -7766,7 +7837,7 @@
               </a:defRPr>
             </a:pPr>
             <a:r>
-              <a:t>   Points older than 90 days are automatically summarized or evicted, eliminating OOM crashes forever.</a:t>
+              <a:t>   Live on-device Memory Inspector monitors point counts, WAL growth, and pending sync buffers.</a:t>
             </a:r>
           </a:p>
         </p:txBody>
@@ -7887,8 +7958,8 @@
         </p:nvSpPr>
         <p:spPr>
           <a:xfrm>
-            <a:off x="4572000" y="164592"/>
-            <a:ext cx="3657600" cy="411480"/>
+            <a:off x="4389120" y="164592"/>
+            <a:ext cx="4023360" cy="411480"/>
           </a:xfrm>
           <a:prstGeom prst="rect">
             <a:avLst/>
@@ -7910,7 +7981,7 @@
               </a:defRPr>
             </a:pPr>
             <a:r>
-              <a:t>Executive Product Showcase</a:t>
+              <a:t>Official qdrant-edge-py 0.8.0 Showcase</a:t>
             </a:r>
           </a:p>
         </p:txBody>
@@ -7946,7 +8017,7 @@
               </a:defRPr>
             </a:pPr>
             <a:r>
-              <a:t>🎙️ Indian English | Slide 07 / 08</a:t>
+              <a:t>🎙️ Indian English | Slide 07 / 09</a:t>
             </a:r>
           </a:p>
         </p:txBody>
@@ -8018,7 +8089,7 @@
               </a:defRPr>
             </a:pPr>
             <a:r>
-              <a:t>Groq LLaMA: No Last-Write-Wins on Safety</a:t>
+              <a:t>Groq LLaMA: No Silent Safety Overwrites</a:t>
             </a:r>
           </a:p>
         </p:txBody>
@@ -8054,7 +8125,7 @@
               </a:defRPr>
             </a:pPr>
             <a:r>
-              <a:t>Guarding human lives against silent database overwrites with AI risk reasoning.</a:t>
+              <a:t>Safety-critical procedure updates require human review and AI risk reasoning.</a:t>
             </a:r>
           </a:p>
         </p:txBody>
@@ -8167,7 +8238,7 @@
               <a:spcAft>
                 <a:spcPts val="1200"/>
               </a:spcAft>
-              <a:defRPr sz="1400" b="1">
+              <a:defRPr sz="1200" b="1">
                 <a:solidFill>
                   <a:srgbClr val="0F172A"/>
                 </a:solidFill>
@@ -8175,7 +8246,7 @@
               </a:defRPr>
             </a:pPr>
             <a:r>
-              <a:t>"Last-write-wins kills people on a factory floor."</a:t>
+              <a:t>"Safety-critical updates require human review — preventing silent overwrites on factory procedures."</a:t>
             </a:r>
           </a:p>
           <a:p>
@@ -8188,7 +8259,7 @@
               </a:defRPr>
             </a:pPr>
             <a:r>
-              <a:t>• Omission Detected by LLaMA-3.3</a:t>
+              <a:t>• Omission Flagged by LLaMA-3.3</a:t>
             </a:r>
           </a:p>
           <a:p>
@@ -8233,7 +8304,7 @@
               </a:defRPr>
             </a:pPr>
             <a:r>
-              <a:t>  Identified risk of 500-bar hydraulic injection and flash fire hazard under hot manifold conditions.</a:t>
+              <a:t>  LLaMA flags risk of 500-bar hydraulic injection and flash fire hazard under hot manifold conditions.</a:t>
             </a:r>
           </a:p>
           <a:p>
@@ -8383,8 +8454,8 @@
         </p:nvSpPr>
         <p:spPr>
           <a:xfrm>
-            <a:off x="4572000" y="164592"/>
-            <a:ext cx="3657600" cy="411480"/>
+            <a:off x="4389120" y="164592"/>
+            <a:ext cx="4023360" cy="411480"/>
           </a:xfrm>
           <a:prstGeom prst="rect">
             <a:avLst/>
@@ -8406,7 +8477,7 @@
               </a:defRPr>
             </a:pPr>
             <a:r>
-              <a:t>Executive Product Showcase</a:t>
+              <a:t>Official qdrant-edge-py 0.8.0 Showcase</a:t>
             </a:r>
           </a:p>
         </p:txBody>
@@ -8442,7 +8513,7 @@
               </a:defRPr>
             </a:pPr>
             <a:r>
-              <a:t>🎙️ Indian English | Slide 08 / 08</a:t>
+              <a:t>🎙️ Indian English | Slide 08 / 09</a:t>
             </a:r>
           </a:p>
         </p:txBody>
@@ -8478,7 +8549,7 @@
               </a:defRPr>
             </a:pPr>
             <a:r>
-              <a:t>BUSINESS VALUE &amp; VISION</a:t>
+              <a:t>ENGINEERING RIGOR</a:t>
             </a:r>
           </a:p>
         </p:txBody>
@@ -8514,7 +8585,7 @@
               </a:defRPr>
             </a:pPr>
             <a:r>
-              <a:t>Enterprise Scale &amp; Transformational ROI</a:t>
+              <a:t>Engineering Proof: Automated Verification Matrix</a:t>
             </a:r>
           </a:p>
         </p:txBody>
@@ -8550,45 +8621,21 @@
               </a:defRPr>
             </a:pPr>
             <a:r>
-              <a:t>Capturing human expertise before it walks out the door.</a:t>
-            </a:r>
-          </a:p>
-        </p:txBody>
-      </p:sp>
-      <p:pic>
-        <p:nvPicPr>
-          <p:cNvPr id="9" name="Picture 8" descr="05_central_knowledge_explorer.png"/>
-          <p:cNvPicPr>
-            <a:picLocks noChangeAspect="1"/>
-          </p:cNvPicPr>
-          <p:nvPr/>
-        </p:nvPicPr>
-        <p:blipFill>
-          <a:blip r:embed="rId2"/>
-          <a:stretch>
-            <a:fillRect/>
-          </a:stretch>
-        </p:blipFill>
+              <a:t>Live automated test suite (verify_demo.py) passing 7/7 verification checks with exit code 0.</a:t>
+            </a:r>
+          </a:p>
+        </p:txBody>
+      </p:sp>
+      <p:sp>
+        <p:nvSpPr>
+          <p:cNvPr id="9" name="Rounded Rectangle 8"/>
+          <p:cNvSpPr/>
+          <p:nvPr/>
+        </p:nvSpPr>
         <p:spPr>
           <a:xfrm>
             <a:off x="731520" y="2240280"/>
-            <a:ext cx="6583680" cy="4389120"/>
-          </a:xfrm>
-          <a:prstGeom prst="rect">
-            <a:avLst/>
-          </a:prstGeom>
-        </p:spPr>
-      </p:pic>
-      <p:sp>
-        <p:nvSpPr>
-          <p:cNvPr id="10" name="Rounded Rectangle 9"/>
-          <p:cNvSpPr/>
-          <p:nvPr/>
-        </p:nvSpPr>
-        <p:spPr>
-          <a:xfrm>
-            <a:off x="7589520" y="2240280"/>
-            <a:ext cx="3840480" cy="3931920"/>
+            <a:ext cx="6858000" cy="3931920"/>
           </a:xfrm>
           <a:prstGeom prst="roundRect">
             <a:avLst/>
@@ -8626,14 +8673,14 @@
       </p:sp>
       <p:sp>
         <p:nvSpPr>
-          <p:cNvPr id="11" name="TextBox 10"/>
+          <p:cNvPr id="10" name="TextBox 9"/>
           <p:cNvSpPr txBox="1"/>
           <p:nvPr/>
         </p:nvSpPr>
         <p:spPr>
           <a:xfrm>
-            <a:off x="7818120" y="2468880"/>
-            <a:ext cx="3383280" cy="3474720"/>
+            <a:off x="914400" y="2423160"/>
+            <a:ext cx="6492240" cy="3566160"/>
           </a:xfrm>
           <a:prstGeom prst="rect">
             <a:avLst/>
@@ -8647,15 +8694,246 @@
           <a:lstStyle/>
           <a:p>
             <a:pPr>
-              <a:defRPr sz="1800" b="1">
+              <a:spcAft>
+                <a:spcPts val="800"/>
+              </a:spcAft>
+              <a:defRPr sz="1500" b="1">
+                <a:solidFill>
+                  <a:srgbClr val="059669"/>
+                </a:solidFill>
+                <a:latin typeface="Segoe UI"/>
+              </a:defRPr>
+            </a:pPr>
+            <a:r>
+              <a:t>Programmatic Verification Results (100% Pass)</a:t>
+            </a:r>
+          </a:p>
+          <a:p>
+            <a:pPr>
+              <a:defRPr sz="1100" b="1">
                 <a:solidFill>
                   <a:srgbClr val="0F172A"/>
                 </a:solidFill>
+                <a:latin typeface="Calibri"/>
+              </a:defRPr>
+            </a:pPr>
+            <a:r>
+              <a:t>✅ [Step 1] Services Health Check: </a:t>
+            </a:r>
+            <a:r>
+              <a:rPr b="0">
+                <a:solidFill>
+                  <a:srgbClr val="475569"/>
+                </a:solidFill>
+              </a:rPr>
+              <a:t>Edge API (:8000), Cloud API (:8001), Next.js Frontend (:3000) verified healthy.</a:t>
+            </a:r>
+          </a:p>
+          <a:p>
+            <a:pPr>
+              <a:defRPr sz="1100" b="1">
+                <a:solidFill>
+                  <a:srgbClr val="0F172A"/>
+                </a:solidFill>
+                <a:latin typeface="Calibri"/>
+              </a:defRPr>
+            </a:pPr>
+            <a:r>
+              <a:t>✅ [Step 2] Airplane Mode Enforcement: </a:t>
+            </a:r>
+            <a:r>
+              <a:rPr b="0">
+                <a:solidFill>
+                  <a:srgbClr val="475569"/>
+                </a:solidFill>
+              </a:rPr>
+              <a:t>Offline toggle active; network requests blocked &amp; deferred as expected.</a:t>
+            </a:r>
+          </a:p>
+          <a:p>
+            <a:pPr>
+              <a:defRPr sz="1100" b="1">
+                <a:solidFill>
+                  <a:srgbClr val="0F172A"/>
+                </a:solidFill>
+                <a:latin typeface="Calibri"/>
+              </a:defRPr>
+            </a:pPr>
+            <a:r>
+              <a:t>✅ [Step 3] Offline Search Execution: </a:t>
+            </a:r>
+            <a:r>
+              <a:rPr b="0">
+                <a:solidFill>
+                  <a:srgbClr val="475569"/>
+                </a:solidFill>
+              </a:rPr>
+              <a:t>Native qdrant_edge.EdgeShard executed vector search in &lt;800ms with zero cloud calls.</a:t>
+            </a:r>
+          </a:p>
+          <a:p>
+            <a:pPr>
+              <a:defRPr sz="1100" b="1">
+                <a:solidFill>
+                  <a:srgbClr val="0F172A"/>
+                </a:solidFill>
+                <a:latin typeface="Calibri"/>
+              </a:defRPr>
+            </a:pPr>
+            <a:r>
+              <a:t>✅ [Step 4] Local Write Staging: </a:t>
+            </a:r>
+            <a:r>
+              <a:rPr b="0">
+                <a:solidFill>
+                  <a:srgbClr val="475569"/>
+                </a:solidFill>
+              </a:rPr>
+              <a:t>New observation logged while offline; staged in pending queue with monotonic sequence ID.</a:t>
+            </a:r>
+          </a:p>
+          <a:p>
+            <a:pPr>
+              <a:defRPr sz="1100" b="1">
+                <a:solidFill>
+                  <a:srgbClr val="0F172A"/>
+                </a:solidFill>
+                <a:latin typeface="Calibri"/>
+              </a:defRPr>
+            </a:pPr>
+            <a:r>
+              <a:t>✅ [Step 5] Memory &amp; Disk Inspection: </a:t>
+            </a:r>
+            <a:r>
+              <a:rPr b="0">
+                <a:solidFill>
+                  <a:srgbClr val="475569"/>
+                </a:solidFill>
+              </a:rPr>
+              <a:t>Inspected native EdgeShard segments, WAL directory, and 384d vector index.</a:t>
+            </a:r>
+          </a:p>
+          <a:p>
+            <a:pPr>
+              <a:defRPr sz="1100" b="1">
+                <a:solidFill>
+                  <a:srgbClr val="0F172A"/>
+                </a:solidFill>
+                <a:latin typeface="Calibri"/>
+              </a:defRPr>
+            </a:pPr>
+            <a:r>
+              <a:t>✅ [Step 6] Reconnection &amp; Delta Sync: </a:t>
+            </a:r>
+            <a:r>
+              <a:rPr b="0">
+                <a:solidFill>
+                  <a:srgbClr val="475569"/>
+                </a:solidFill>
+              </a:rPr>
+              <a:t>Network toggled online; pushed staged writes and pulled 7 central updates cleanly.</a:t>
+            </a:r>
+          </a:p>
+          <a:p>
+            <a:pPr>
+              <a:defRPr sz="1100" b="1">
+                <a:solidFill>
+                  <a:srgbClr val="0F172A"/>
+                </a:solidFill>
+                <a:latin typeface="Calibri"/>
+              </a:defRPr>
+            </a:pPr>
+            <a:r>
+              <a:t>✅ [Step 7] Central Conflict &amp; AI Reasoning: </a:t>
+            </a:r>
+            <a:r>
+              <a:rPr b="0">
+                <a:solidFill>
+                  <a:srgbClr val="475569"/>
+                </a:solidFill>
+              </a:rPr>
+              <a:t>LOTO safety conflict inspected in central queue with live Groq LLaMA reasoning preview.</a:t>
+            </a:r>
+          </a:p>
+        </p:txBody>
+      </p:sp>
+      <p:sp>
+        <p:nvSpPr>
+          <p:cNvPr id="11" name="Rounded Rectangle 10"/>
+          <p:cNvSpPr/>
+          <p:nvPr/>
+        </p:nvSpPr>
+        <p:spPr>
+          <a:xfrm>
+            <a:off x="7772400" y="2240280"/>
+            <a:ext cx="3657600" cy="3931920"/>
+          </a:xfrm>
+          <a:prstGeom prst="roundRect">
+            <a:avLst/>
+          </a:prstGeom>
+          <a:solidFill>
+            <a:srgbClr val="FFFFFF"/>
+          </a:solidFill>
+          <a:ln w="19050">
+            <a:solidFill>
+              <a:srgbClr val="E2E8F0"/>
+            </a:solidFill>
+          </a:ln>
+        </p:spPr>
+        <p:style>
+          <a:lnRef idx="1">
+            <a:schemeClr val="accent1"/>
+          </a:lnRef>
+          <a:fillRef idx="3">
+            <a:schemeClr val="accent1"/>
+          </a:fillRef>
+          <a:effectRef idx="2">
+            <a:schemeClr val="accent1"/>
+          </a:effectRef>
+          <a:fontRef idx="minor">
+            <a:schemeClr val="lt1"/>
+          </a:fontRef>
+        </p:style>
+        <p:txBody>
+          <a:bodyPr rtlCol="0" anchor="ctr"/>
+          <a:lstStyle/>
+          <a:p>
+            <a:pPr algn="ctr"/>
+          </a:p>
+        </p:txBody>
+      </p:sp>
+      <p:sp>
+        <p:nvSpPr>
+          <p:cNvPr id="12" name="TextBox 11"/>
+          <p:cNvSpPr txBox="1"/>
+          <p:nvPr/>
+        </p:nvSpPr>
+        <p:spPr>
+          <a:xfrm>
+            <a:off x="8001000" y="2468880"/>
+            <a:ext cx="3200400" cy="3474720"/>
+          </a:xfrm>
+          <a:prstGeom prst="rect">
+            <a:avLst/>
+          </a:prstGeom>
+          <a:noFill/>
+        </p:spPr>
+        <p:txBody>
+          <a:bodyPr wrap="square">
+            <a:spAutoFit/>
+          </a:bodyPr>
+          <a:lstStyle/>
+          <a:p>
+            <a:pPr>
+              <a:defRPr sz="1400" b="1">
+                <a:solidFill>
+                  <a:srgbClr val="0F172A"/>
+                </a:solidFill>
                 <a:latin typeface="Segoe UI"/>
               </a:defRPr>
             </a:pPr>
             <a:r>
-              <a:t>Measurable Enterprise ROI</a:t>
+              <a:t>VALIDATED ENVIRONMENT</a:t>
             </a:r>
           </a:p>
           <a:p>
@@ -8663,7 +8941,7 @@
               <a:spcAft>
                 <a:spcPts val="400"/>
               </a:spcAft>
-              <a:defRPr sz="3800" b="1">
+              <a:defRPr sz="2800" b="1">
                 <a:solidFill>
                   <a:srgbClr val="059669"/>
                 </a:solidFill>
@@ -8671,7 +8949,521 @@
               </a:defRPr>
             </a:pPr>
             <a:r>
-              <a:t>18x ROI</a:t>
+              <a:t>7 / 7 PASSED</a:t>
+            </a:r>
+          </a:p>
+          <a:p>
+            <a:pPr>
+              <a:defRPr sz="1100" b="1">
+                <a:solidFill>
+                  <a:srgbClr val="2563EB"/>
+                </a:solidFill>
+                <a:latin typeface="Segoe UI"/>
+              </a:defRPr>
+            </a:pPr>
+            <a:r>
+              <a:t>• qdrant-edge-py: </a:t>
+            </a:r>
+            <a:r>
+              <a:rPr b="0">
+                <a:solidFill>
+                  <a:srgbClr val="475569"/>
+                </a:solidFill>
+              </a:rPr>
+              <a:t>==0.8.0 (Native EdgeShard bindings)</a:t>
+            </a:r>
+          </a:p>
+          <a:p>
+            <a:pPr>
+              <a:defRPr sz="1100" b="1">
+                <a:solidFill>
+                  <a:srgbClr val="2563EB"/>
+                </a:solidFill>
+                <a:latin typeface="Segoe UI"/>
+              </a:defRPr>
+            </a:pPr>
+            <a:r>
+              <a:t>• Embeddings: </a:t>
+            </a:r>
+            <a:r>
+              <a:rPr b="0">
+                <a:solidFill>
+                  <a:srgbClr val="475569"/>
+                </a:solidFill>
+              </a:rPr>
+              <a:t>FastEmbed BGE-small-en-v1.5 (384d)</a:t>
+            </a:r>
+          </a:p>
+          <a:p>
+            <a:pPr>
+              <a:defRPr sz="1100" b="1">
+                <a:solidFill>
+                  <a:srgbClr val="2563EB"/>
+                </a:solidFill>
+                <a:latin typeface="Segoe UI"/>
+              </a:defRPr>
+            </a:pPr>
+            <a:r>
+              <a:t>• Runtime OS: </a:t>
+            </a:r>
+            <a:r>
+              <a:rPr b="0">
+                <a:solidFill>
+                  <a:srgbClr val="475569"/>
+                </a:solidFill>
+              </a:rPr>
+              <a:t>Windows 11 x64 / Python 3.13</a:t>
+            </a:r>
+          </a:p>
+          <a:p>
+            <a:pPr>
+              <a:defRPr sz="1100" b="1">
+                <a:solidFill>
+                  <a:srgbClr val="2563EB"/>
+                </a:solidFill>
+                <a:latin typeface="Segoe UI"/>
+              </a:defRPr>
+            </a:pPr>
+            <a:r>
+              <a:t>• Observed Latency: </a:t>
+            </a:r>
+            <a:r>
+              <a:rPr b="0">
+                <a:solidFill>
+                  <a:srgbClr val="475569"/>
+                </a:solidFill>
+              </a:rPr>
+              <a:t>~100–135ms warm cache (&lt;200ms passed)</a:t>
+            </a:r>
+          </a:p>
+          <a:p>
+            <a:pPr>
+              <a:defRPr sz="1100" b="1">
+                <a:solidFill>
+                  <a:srgbClr val="2563EB"/>
+                </a:solidFill>
+                <a:latin typeface="Segoe UI"/>
+              </a:defRPr>
+            </a:pPr>
+            <a:r>
+              <a:t>• Audit Script: </a:t>
+            </a:r>
+            <a:r>
+              <a:rPr b="0">
+                <a:solidFill>
+                  <a:srgbClr val="475569"/>
+                </a:solidFill>
+              </a:rPr>
+              <a:t>python verify_demo.py (exit code 0)</a:t>
+            </a:r>
+          </a:p>
+        </p:txBody>
+      </p:sp>
+    </p:spTree>
+  </p:cSld>
+  <p:clrMapOvr>
+    <a:masterClrMapping/>
+  </p:clrMapOvr>
+</p:sld>
+</file>
+
+<file path=ppt/slides/slide9.xml><?xml version="1.0" encoding="utf-8"?>
+<p:sld xmlns:a="http://schemas.openxmlformats.org/drawingml/2006/main" xmlns:p="http://schemas.openxmlformats.org/presentationml/2006/main" xmlns:r="http://schemas.openxmlformats.org/officeDocument/2006/relationships">
+  <p:cSld>
+    <p:spTree>
+      <p:nvGrpSpPr>
+        <p:cNvPr id="1" name=""/>
+        <p:cNvGrpSpPr/>
+        <p:nvPr/>
+      </p:nvGrpSpPr>
+      <p:grpSpPr/>
+      <p:sp>
+        <p:nvSpPr>
+          <p:cNvPr id="2" name="Rectangle 1"/>
+          <p:cNvSpPr/>
+          <p:nvPr/>
+        </p:nvSpPr>
+        <p:spPr>
+          <a:xfrm>
+            <a:off x="0" y="0"/>
+            <a:ext cx="12191695" cy="731520"/>
+          </a:xfrm>
+          <a:prstGeom prst="rect">
+            <a:avLst/>
+          </a:prstGeom>
+          <a:solidFill>
+            <a:srgbClr val="FFFFFF"/>
+          </a:solidFill>
+          <a:ln w="12700">
+            <a:solidFill>
+              <a:srgbClr val="E2E8F0"/>
+            </a:solidFill>
+          </a:ln>
+        </p:spPr>
+        <p:style>
+          <a:lnRef idx="1">
+            <a:schemeClr val="accent1"/>
+          </a:lnRef>
+          <a:fillRef idx="3">
+            <a:schemeClr val="accent1"/>
+          </a:fillRef>
+          <a:effectRef idx="2">
+            <a:schemeClr val="accent1"/>
+          </a:effectRef>
+          <a:fontRef idx="minor">
+            <a:schemeClr val="lt1"/>
+          </a:fontRef>
+        </p:style>
+        <p:txBody>
+          <a:bodyPr rtlCol="0" anchor="ctr"/>
+          <a:lstStyle/>
+          <a:p>
+            <a:pPr algn="ctr"/>
+          </a:p>
+        </p:txBody>
+      </p:sp>
+      <p:sp>
+        <p:nvSpPr>
+          <p:cNvPr id="3" name="TextBox 2"/>
+          <p:cNvSpPr txBox="1"/>
+          <p:nvPr/>
+        </p:nvSpPr>
+        <p:spPr>
+          <a:xfrm>
+            <a:off x="548640" y="137160"/>
+            <a:ext cx="4114800" cy="457200"/>
+          </a:xfrm>
+          <a:prstGeom prst="rect">
+            <a:avLst/>
+          </a:prstGeom>
+          <a:noFill/>
+        </p:spPr>
+        <p:txBody>
+          <a:bodyPr wrap="square">
+            <a:spAutoFit/>
+          </a:bodyPr>
+          <a:lstStyle/>
+          <a:p>
+            <a:pPr>
+              <a:defRPr sz="1500" b="1">
+                <a:solidFill>
+                  <a:srgbClr val="0F172A"/>
+                </a:solidFill>
+                <a:latin typeface="Segoe UI"/>
+              </a:defRPr>
+            </a:pPr>
+            <a:r>
+              <a:t>🏭 PlantMind Edge  </a:t>
+            </a:r>
+            <a:r>
+              <a:rPr sz="1100" b="1">
+                <a:solidFill>
+                  <a:srgbClr val="D97706"/>
+                </a:solidFill>
+                <a:latin typeface="Calibri"/>
+              </a:rPr>
+              <a:t>[ Qdrant Hackathon ]</a:t>
+            </a:r>
+          </a:p>
+        </p:txBody>
+      </p:sp>
+      <p:sp>
+        <p:nvSpPr>
+          <p:cNvPr id="4" name="TextBox 3"/>
+          <p:cNvSpPr txBox="1"/>
+          <p:nvPr/>
+        </p:nvSpPr>
+        <p:spPr>
+          <a:xfrm>
+            <a:off x="4389120" y="164592"/>
+            <a:ext cx="4023360" cy="411480"/>
+          </a:xfrm>
+          <a:prstGeom prst="rect">
+            <a:avLst/>
+          </a:prstGeom>
+          <a:noFill/>
+        </p:spPr>
+        <p:txBody>
+          <a:bodyPr wrap="none">
+            <a:spAutoFit/>
+          </a:bodyPr>
+          <a:lstStyle/>
+          <a:p>
+            <a:pPr algn="ctr">
+              <a:defRPr sz="1100">
+                <a:solidFill>
+                  <a:srgbClr val="475569"/>
+                </a:solidFill>
+                <a:latin typeface="Calibri"/>
+              </a:defRPr>
+            </a:pPr>
+            <a:r>
+              <a:t>Official qdrant-edge-py 0.8.0 Showcase</a:t>
+            </a:r>
+          </a:p>
+        </p:txBody>
+      </p:sp>
+      <p:sp>
+        <p:nvSpPr>
+          <p:cNvPr id="5" name="TextBox 4"/>
+          <p:cNvSpPr txBox="1"/>
+          <p:nvPr/>
+        </p:nvSpPr>
+        <p:spPr>
+          <a:xfrm>
+            <a:off x="8412480" y="164592"/>
+            <a:ext cx="3200400" cy="411480"/>
+          </a:xfrm>
+          <a:prstGeom prst="rect">
+            <a:avLst/>
+          </a:prstGeom>
+          <a:noFill/>
+        </p:spPr>
+        <p:txBody>
+          <a:bodyPr wrap="none">
+            <a:spAutoFit/>
+          </a:bodyPr>
+          <a:lstStyle/>
+          <a:p>
+            <a:pPr algn="r">
+              <a:defRPr sz="1100" b="1">
+                <a:solidFill>
+                  <a:srgbClr val="475569"/>
+                </a:solidFill>
+                <a:latin typeface="Calibri"/>
+              </a:defRPr>
+            </a:pPr>
+            <a:r>
+              <a:t>🎙️ Indian English | Slide 09 / 09</a:t>
+            </a:r>
+          </a:p>
+        </p:txBody>
+      </p:sp>
+      <p:sp>
+        <p:nvSpPr>
+          <p:cNvPr id="6" name="TextBox 5"/>
+          <p:cNvSpPr txBox="1"/>
+          <p:nvPr/>
+        </p:nvSpPr>
+        <p:spPr>
+          <a:xfrm>
+            <a:off x="731520" y="868680"/>
+            <a:ext cx="10515600" cy="320040"/>
+          </a:xfrm>
+          <a:prstGeom prst="rect">
+            <a:avLst/>
+          </a:prstGeom>
+          <a:noFill/>
+        </p:spPr>
+        <p:txBody>
+          <a:bodyPr wrap="none">
+            <a:spAutoFit/>
+          </a:bodyPr>
+          <a:lstStyle/>
+          <a:p>
+            <a:pPr>
+              <a:defRPr sz="1000" b="1">
+                <a:solidFill>
+                  <a:srgbClr val="D97706"/>
+                </a:solidFill>
+                <a:latin typeface="Segoe UI"/>
+              </a:defRPr>
+            </a:pPr>
+            <a:r>
+              <a:t>BUSINESS VALUE &amp; VISION</a:t>
+            </a:r>
+          </a:p>
+        </p:txBody>
+      </p:sp>
+      <p:sp>
+        <p:nvSpPr>
+          <p:cNvPr id="7" name="TextBox 6"/>
+          <p:cNvSpPr txBox="1"/>
+          <p:nvPr/>
+        </p:nvSpPr>
+        <p:spPr>
+          <a:xfrm>
+            <a:off x="731520" y="1115568"/>
+            <a:ext cx="10515600" cy="594360"/>
+          </a:xfrm>
+          <a:prstGeom prst="rect">
+            <a:avLst/>
+          </a:prstGeom>
+          <a:noFill/>
+        </p:spPr>
+        <p:txBody>
+          <a:bodyPr wrap="none">
+            <a:spAutoFit/>
+          </a:bodyPr>
+          <a:lstStyle/>
+          <a:p>
+            <a:pPr>
+              <a:defRPr sz="2600" b="1">
+                <a:solidFill>
+                  <a:srgbClr val="0F172A"/>
+                </a:solidFill>
+                <a:latin typeface="Segoe UI"/>
+              </a:defRPr>
+            </a:pPr>
+            <a:r>
+              <a:t>Enterprise Deployment &amp; Downtime Avoidance</a:t>
+            </a:r>
+          </a:p>
+        </p:txBody>
+      </p:sp>
+      <p:sp>
+        <p:nvSpPr>
+          <p:cNvPr id="8" name="TextBox 7"/>
+          <p:cNvSpPr txBox="1"/>
+          <p:nvPr/>
+        </p:nvSpPr>
+        <p:spPr>
+          <a:xfrm>
+            <a:off x="731520" y="1691640"/>
+            <a:ext cx="10515600" cy="411480"/>
+          </a:xfrm>
+          <a:prstGeom prst="rect">
+            <a:avLst/>
+          </a:prstGeom>
+          <a:noFill/>
+        </p:spPr>
+        <p:txBody>
+          <a:bodyPr wrap="none">
+            <a:spAutoFit/>
+          </a:bodyPr>
+          <a:lstStyle/>
+          <a:p>
+            <a:pPr>
+              <a:defRPr sz="1300">
+                <a:solidFill>
+                  <a:srgbClr val="475569"/>
+                </a:solidFill>
+                <a:latin typeface="Calibri"/>
+              </a:defRPr>
+            </a:pPr>
+            <a:r>
+              <a:t>Capturing tribal expertise before it walks out the door.</a:t>
+            </a:r>
+          </a:p>
+        </p:txBody>
+      </p:sp>
+      <p:pic>
+        <p:nvPicPr>
+          <p:cNvPr id="9" name="Picture 8" descr="05_central_knowledge_explorer.png"/>
+          <p:cNvPicPr>
+            <a:picLocks noChangeAspect="1"/>
+          </p:cNvPicPr>
+          <p:nvPr/>
+        </p:nvPicPr>
+        <p:blipFill>
+          <a:blip r:embed="rId2"/>
+          <a:stretch>
+            <a:fillRect/>
+          </a:stretch>
+        </p:blipFill>
+        <p:spPr>
+          <a:xfrm>
+            <a:off x="731520" y="2240280"/>
+            <a:ext cx="6583680" cy="4389120"/>
+          </a:xfrm>
+          <a:prstGeom prst="rect">
+            <a:avLst/>
+          </a:prstGeom>
+        </p:spPr>
+      </p:pic>
+      <p:sp>
+        <p:nvSpPr>
+          <p:cNvPr id="10" name="Rounded Rectangle 9"/>
+          <p:cNvSpPr/>
+          <p:nvPr/>
+        </p:nvSpPr>
+        <p:spPr>
+          <a:xfrm>
+            <a:off x="7589520" y="2240280"/>
+            <a:ext cx="3840480" cy="3931920"/>
+          </a:xfrm>
+          <a:prstGeom prst="roundRect">
+            <a:avLst/>
+          </a:prstGeom>
+          <a:solidFill>
+            <a:srgbClr val="FFFFFF"/>
+          </a:solidFill>
+          <a:ln w="25400">
+            <a:solidFill>
+              <a:srgbClr val="059669"/>
+            </a:solidFill>
+          </a:ln>
+        </p:spPr>
+        <p:style>
+          <a:lnRef idx="1">
+            <a:schemeClr val="accent1"/>
+          </a:lnRef>
+          <a:fillRef idx="3">
+            <a:schemeClr val="accent1"/>
+          </a:fillRef>
+          <a:effectRef idx="2">
+            <a:schemeClr val="accent1"/>
+          </a:effectRef>
+          <a:fontRef idx="minor">
+            <a:schemeClr val="lt1"/>
+          </a:fontRef>
+        </p:style>
+        <p:txBody>
+          <a:bodyPr rtlCol="0" anchor="ctr"/>
+          <a:lstStyle/>
+          <a:p>
+            <a:pPr algn="ctr"/>
+          </a:p>
+        </p:txBody>
+      </p:sp>
+      <p:sp>
+        <p:nvSpPr>
+          <p:cNvPr id="11" name="TextBox 10"/>
+          <p:cNvSpPr txBox="1"/>
+          <p:nvPr/>
+        </p:nvSpPr>
+        <p:spPr>
+          <a:xfrm>
+            <a:off x="7818120" y="2468880"/>
+            <a:ext cx="3383280" cy="3474720"/>
+          </a:xfrm>
+          <a:prstGeom prst="rect">
+            <a:avLst/>
+          </a:prstGeom>
+          <a:noFill/>
+        </p:spPr>
+        <p:txBody>
+          <a:bodyPr wrap="square">
+            <a:spAutoFit/>
+          </a:bodyPr>
+          <a:lstStyle/>
+          <a:p>
+            <a:pPr>
+              <a:defRPr sz="1700" b="1">
+                <a:solidFill>
+                  <a:srgbClr val="0F172A"/>
+                </a:solidFill>
+                <a:latin typeface="Segoe UI"/>
+              </a:defRPr>
+            </a:pPr>
+            <a:r>
+              <a:t>Potential Downtime Avoidance</a:t>
+            </a:r>
+          </a:p>
+          <a:p>
+            <a:pPr>
+              <a:spcAft>
+                <a:spcPts val="200"/>
+              </a:spcAft>
+              <a:defRPr sz="3600" b="1">
+                <a:solidFill>
+                  <a:srgbClr val="059669"/>
+                </a:solidFill>
+                <a:latin typeface="Segoe UI"/>
+              </a:defRPr>
+            </a:pPr>
+            <a:r>
+              <a:t>$2.6M</a:t>
             </a:r>
           </a:p>
           <a:p>
@@ -8687,7 +9479,7 @@
               </a:defRPr>
             </a:pPr>
             <a:r>
-              <a:t>A single avoided 2-hour downtime incident saves $2.6M — paying for PlantMind Edge across an entire factory facility for years.</a:t>
+              <a:t>Illustrative value of avoiding a single 2-hour downtime event at the stated $22K/minute assumption.</a:t>
             </a:r>
           </a:p>
           <a:p>
@@ -8700,7 +9492,7 @@
               </a:defRPr>
             </a:pPr>
             <a:r>
-              <a:t>✓ $14.2B Addressable Market</a:t>
+              <a:t>✓ Enterprise Deployment</a:t>
             </a:r>
           </a:p>
           <a:p>
@@ -8716,7 +9508,7 @@
               </a:defRPr>
             </a:pPr>
             <a:r>
-              <a:t>   Connected worker and industrial edge intelligence sector growing at 24% CAGR.</a:t>
+              <a:t>   Per-facility deployment designed around avoided downtime and knowledge continuity.</a:t>
             </a:r>
           </a:p>
           <a:p>
@@ -8745,7 +9537,7 @@
               </a:defRPr>
             </a:pPr>
             <a:r>
-              <a:t>   Synchronizes maintenance best practices across multiple factories worldwide with Qdrant.</a:t>
+              <a:t>   Central Qdrant synchronizes verified maintenance solutions across multi-plant operations.</a:t>
             </a:r>
           </a:p>
         </p:txBody>

</xml_diff>